<commit_message>
feat(presentation): integrate live Streamlit application screenshots into presentation decks
</commit_message>
<xml_diff>
--- a/presentation/Kolkata_FoodLens_Minor_Project_Presentation.pptx
+++ b/presentation/Kolkata_FoodLens_Minor_Project_Presentation.pptx
@@ -9744,19 +9744,16 @@
           </a:bodyPr>
           <a:lstStyle/>
           <a:p>
-            <a:pPr algn="l">
-              <a:spcAft>
-                <a:spcPts val="300"/>
-              </a:spcAft>
+            <a:pPr>
+              <a:defRPr sz="1100">
+                <a:solidFill>
+                  <a:srgbClr val="475569"/>
+                </a:solidFill>
+                <a:latin typeface="Arial"/>
+              </a:defRPr>
             </a:pPr>
             <a:r>
-              <a:rPr sz="1080" b="0" i="0">
-                <a:solidFill>
-                  <a:srgbClr val="263445"/>
-                </a:solidFill>
-                <a:latin typeface="Aptos"/>
-              </a:rPr>
-              <a:t>A user enters a review and the saved text-classification pipeline returns a sentiment label. Training is done offline; the website performs inference.</a:t>
+              <a:t>Users input custom dining reviews or select sample queries; the saved pipeline performs real-time sentiment classification and aspect polarity extraction.</a:t>
             </a:r>
           </a:p>
         </p:txBody>

</xml_diff>

<commit_message>
fix(presentation): polish slide typography, align headers, center accent bars, and refine live app screenshot framing
</commit_message>
<xml_diff>
--- a/presentation/Kolkata_FoodLens_Minor_Project_Presentation.pptx
+++ b/presentation/Kolkata_FoodLens_Minor_Project_Presentation.pptx
@@ -3704,7 +3704,12 @@
             <p:ph type="ctrTitle"/>
           </p:nvPr>
         </p:nvSpPr>
-        <p:spPr/>
+        <p:spPr>
+          <a:xfrm>
+            <a:off x="1097280" y="1234440"/>
+            <a:ext cx="10003536" cy="2011680"/>
+          </a:xfrm>
+        </p:spPr>
         <p:txBody>
           <a:bodyPr wrap="square" lIns="109728" rIns="109728" tIns="109728" bIns="109728" anchor="ctr"/>
           <a:lstStyle/>
@@ -3713,6 +3718,12 @@
               <a:spcAft>
                 <a:spcPts val="300"/>
               </a:spcAft>
+              <a:defRPr sz="3200" b="1">
+                <a:solidFill>
+                  <a:srgbClr val="1E293B"/>
+                </a:solidFill>
+                <a:latin typeface="Arial"/>
+              </a:defRPr>
             </a:pPr>
             <a:r>
               <a:rPr sz="2700" b="1" i="0">
@@ -3729,6 +3740,12 @@
               <a:spcAft>
                 <a:spcPts val="300"/>
               </a:spcAft>
+              <a:defRPr sz="3200" b="1">
+                <a:solidFill>
+                  <a:srgbClr val="1E293B"/>
+                </a:solidFill>
+                <a:latin typeface="Arial"/>
+              </a:defRPr>
             </a:pPr>
             <a:r>
               <a:rPr sz="2700" b="1" i="0">
@@ -3758,7 +3775,12 @@
             <p:ph type="subTitle" idx="1"/>
           </p:nvPr>
         </p:nvSpPr>
-        <p:spPr/>
+        <p:spPr>
+          <a:xfrm>
+            <a:off x="1097280" y="3611880"/>
+            <a:ext cx="10003536" cy="1828800"/>
+          </a:xfrm>
+        </p:spPr>
         <p:txBody>
           <a:bodyPr wrap="square" lIns="54864" rIns="54864" tIns="54864" bIns="54864" anchor="ctr">
             <a:noAutofit/>
@@ -3766,82 +3788,54 @@
           <a:lstStyle/>
           <a:p>
             <a:pPr algn="ctr">
-              <a:spcAft>
-                <a:spcPts val="300"/>
-              </a:spcAft>
+              <a:defRPr sz="1300">
+                <a:solidFill>
+                  <a:srgbClr val="475569"/>
+                </a:solidFill>
+                <a:latin typeface="Arial"/>
+              </a:defRPr>
             </a:pPr>
             <a:r>
-              <a:rPr sz="1300" b="0" i="0">
-                <a:solidFill>
-                  <a:srgbClr val="263445"/>
-                </a:solidFill>
-                <a:latin typeface="Aptos"/>
-              </a:rPr>
               <a:t>Authors: Tanim Naha, [Member 2], [Member 3]</a:t>
             </a:r>
           </a:p>
           <a:p>
             <a:pPr algn="ctr">
-              <a:spcAft>
-                <a:spcPts val="300"/>
-              </a:spcAft>
+              <a:defRPr sz="1300">
+                <a:solidFill>
+                  <a:srgbClr val="475569"/>
+                </a:solidFill>
+                <a:latin typeface="Arial"/>
+              </a:defRPr>
             </a:pPr>
             <a:r>
-              <a:rPr sz="1300" b="0" i="0">
-                <a:solidFill>
-                  <a:srgbClr val="263445"/>
-                </a:solidFill>
-                <a:latin typeface="Aptos"/>
-              </a:rPr>
-              <a:t>B.Tech CSE  |  Semester: [Insert Semester]  |  Academic Year: 2026–2027</a:t>
+              <a:t>B.Tech CSE  |  7th Semester  |  Academic Year: 2026–2027</a:t>
             </a:r>
           </a:p>
           <a:p>
             <a:pPr algn="ctr">
-              <a:spcAft>
-                <a:spcPts val="300"/>
-              </a:spcAft>
+              <a:defRPr sz="1300">
+                <a:solidFill>
+                  <a:srgbClr val="475569"/>
+                </a:solidFill>
+                <a:latin typeface="Arial"/>
+              </a:defRPr>
             </a:pPr>
             <a:r>
-              <a:rPr sz="1300" b="0" i="0">
-                <a:solidFill>
-                  <a:srgbClr val="263445"/>
-                </a:solidFill>
-                <a:latin typeface="Aptos"/>
-              </a:rPr>
-              <a:t>Amity School of Engineering &amp; Technology</a:t>
+              <a:t>Amity School of Engineering &amp; Technology, Amity University, Kolkata</a:t>
             </a:r>
           </a:p>
           <a:p>
             <a:pPr algn="ctr">
-              <a:spcAft>
-                <a:spcPts val="300"/>
-              </a:spcAft>
+              <a:defRPr sz="1300">
+                <a:solidFill>
+                  <a:srgbClr val="475569"/>
+                </a:solidFill>
+                <a:latin typeface="Arial"/>
+              </a:defRPr>
             </a:pPr>
             <a:r>
-              <a:rPr sz="1300" b="0" i="0">
-                <a:solidFill>
-                  <a:srgbClr val="263445"/>
-                </a:solidFill>
-                <a:latin typeface="Aptos"/>
-              </a:rPr>
-              <a:t>Amity University, Kolkata</a:t>
-            </a:r>
-          </a:p>
-          <a:p>
-            <a:pPr algn="ctr">
-              <a:spcAft>
-                <a:spcPts val="300"/>
-              </a:spcAft>
-            </a:pPr>
-            <a:r>
-              <a:rPr sz="1300" b="0" i="0">
-                <a:solidFill>
-                  <a:srgbClr val="263445"/>
-                </a:solidFill>
-                <a:latin typeface="Aptos"/>
-              </a:rPr>
-              <a:t>Minor Project (ETMN100)  |  Faculty Guide: [Insert Name]</a:t>
+              <a:t>Minor Project (ETMN100)  |  Faculty Guide: [Guide Name]</a:t>
             </a:r>
           </a:p>
         </p:txBody>
@@ -3930,7 +3924,7 @@
         </p:nvSpPr>
         <p:spPr>
           <a:xfrm>
-            <a:off x="5449824" y="896112"/>
+            <a:off x="5449824" y="3364992"/>
             <a:ext cx="1298448" cy="54864"/>
           </a:xfrm>
           <a:prstGeom prst="rect">
@@ -4037,29 +4031,6 @@
       </p:sp>
       <p:sp>
         <p:nvSpPr>
-          <p:cNvPr id="3" name="Content Placeholder 2">
-            <a:extLst>
-              <a:ext uri="{FF2B5EF4-FFF2-40B4-BE49-F238E27FC236}">
-                <a16:creationId xmlns:a16="http://schemas.microsoft.com/office/drawing/2014/main" id="{968F2315-DF31-8F90-F6FC-DE3B766FAD0D}"/>
-              </a:ext>
-            </a:extLst>
-          </p:cNvPr>
-          <p:cNvSpPr>
-            <a:spLocks noGrp="1"/>
-          </p:cNvSpPr>
-          <p:nvPr>
-            <p:ph idx="1"/>
-          </p:nvPr>
-        </p:nvSpPr>
-        <p:spPr/>
-        <p:txBody>
-          <a:bodyPr/>
-          <a:lstStyle/>
-          <a:p/>
-        </p:txBody>
-      </p:sp>
-      <p:sp>
-        <p:nvSpPr>
           <p:cNvPr id="4" name="TextBox 3">
             <a:extLst>
               <a:ext uri="{FF2B5EF4-FFF2-40B4-BE49-F238E27FC236}">
@@ -5113,8 +5084,8 @@
         </p:nvSpPr>
         <p:spPr>
           <a:xfrm>
-            <a:off x="365975" y="389225"/>
-            <a:ext cx="8520600" cy="572700"/>
+            <a:off x="841248" y="365760"/>
+            <a:ext cx="10515600" cy="572700"/>
           </a:xfrm>
           <a:prstGeom prst="rect">
             <a:avLst/>
@@ -5134,218 +5105,18 @@
                 <a:spcPts val="0"/>
               </a:spcAft>
               <a:buNone/>
+              <a:defRPr b="1" sz="2800">
+                <a:solidFill>
+                  <a:srgbClr val="1E293B"/>
+                </a:solidFill>
+                <a:latin typeface="Arial"/>
+              </a:defRPr>
             </a:pPr>
             <a:r>
               <a:rPr lang="en" b="1" dirty="0"/>
               <a:t>Table of Contents</a:t>
             </a:r>
             <a:endParaRPr b="1" dirty="0"/>
-          </a:p>
-        </p:txBody>
-      </p:sp>
-      <p:sp>
-        <p:nvSpPr>
-          <p:cNvPr id="5" name="Google Shape;85;p14">
-            <a:extLst>
-              <a:ext uri="{FF2B5EF4-FFF2-40B4-BE49-F238E27FC236}">
-                <a16:creationId xmlns:a16="http://schemas.microsoft.com/office/drawing/2014/main" id="{E890AAC6-1C1C-40DE-1106-54C7A29614B7}"/>
-              </a:ext>
-            </a:extLst>
-          </p:cNvPr>
-          <p:cNvSpPr txBox="1">
-            <a:spLocks/>
-          </p:cNvSpPr>
-          <p:nvPr/>
-        </p:nvSpPr>
-        <p:spPr>
-          <a:xfrm>
-            <a:off x="365975" y="1441233"/>
-            <a:ext cx="8520600" cy="3416400"/>
-          </a:xfrm>
-          <a:prstGeom prst="rect">
-            <a:avLst/>
-          </a:prstGeom>
-        </p:spPr>
-        <p:txBody>
-          <a:bodyPr spcFirstLastPara="1" vert="horz" wrap="square" lIns="91425" tIns="91425" rIns="91425" bIns="91425" rtlCol="0" anchor="t" anchorCtr="0">
-            <a:normAutofit/>
-          </a:bodyPr>
-          <a:lstStyle>
-            <a:lvl1pPr marL="228600" indent="-228600" algn="l" defTabSz="914400" rtl="0" eaLnBrk="1" latinLnBrk="0" hangingPunct="1">
-              <a:lnSpc>
-                <a:spcPct val="90000"/>
-              </a:lnSpc>
-              <a:spcBef>
-                <a:spcPts val="1000"/>
-              </a:spcBef>
-              <a:buFont typeface="Arial" panose="020B0604020202020204" pitchFamily="34" charset="0"/>
-              <a:buChar char="•"/>
-              <a:defRPr sz="2800" kern="1200">
-                <a:solidFill>
-                  <a:schemeClr val="tx1"/>
-                </a:solidFill>
-                <a:latin typeface="+mn-lt"/>
-                <a:ea typeface="+mn-ea"/>
-                <a:cs typeface="+mn-cs"/>
-              </a:defRPr>
-            </a:lvl1pPr>
-            <a:lvl2pPr marL="685800" indent="-228600" algn="l" defTabSz="914400" rtl="0" eaLnBrk="1" latinLnBrk="0" hangingPunct="1">
-              <a:lnSpc>
-                <a:spcPct val="90000"/>
-              </a:lnSpc>
-              <a:spcBef>
-                <a:spcPts val="500"/>
-              </a:spcBef>
-              <a:buFont typeface="Arial" panose="020B0604020202020204" pitchFamily="34" charset="0"/>
-              <a:buChar char="•"/>
-              <a:defRPr sz="2400" kern="1200">
-                <a:solidFill>
-                  <a:schemeClr val="tx1"/>
-                </a:solidFill>
-                <a:latin typeface="+mn-lt"/>
-                <a:ea typeface="+mn-ea"/>
-                <a:cs typeface="+mn-cs"/>
-              </a:defRPr>
-            </a:lvl2pPr>
-            <a:lvl3pPr marL="1143000" indent="-228600" algn="l" defTabSz="914400" rtl="0" eaLnBrk="1" latinLnBrk="0" hangingPunct="1">
-              <a:lnSpc>
-                <a:spcPct val="90000"/>
-              </a:lnSpc>
-              <a:spcBef>
-                <a:spcPts val="500"/>
-              </a:spcBef>
-              <a:buFont typeface="Arial" panose="020B0604020202020204" pitchFamily="34" charset="0"/>
-              <a:buChar char="•"/>
-              <a:defRPr sz="2000" kern="1200">
-                <a:solidFill>
-                  <a:schemeClr val="tx1"/>
-                </a:solidFill>
-                <a:latin typeface="+mn-lt"/>
-                <a:ea typeface="+mn-ea"/>
-                <a:cs typeface="+mn-cs"/>
-              </a:defRPr>
-            </a:lvl3pPr>
-            <a:lvl4pPr marL="1600200" indent="-228600" algn="l" defTabSz="914400" rtl="0" eaLnBrk="1" latinLnBrk="0" hangingPunct="1">
-              <a:lnSpc>
-                <a:spcPct val="90000"/>
-              </a:lnSpc>
-              <a:spcBef>
-                <a:spcPts val="500"/>
-              </a:spcBef>
-              <a:buFont typeface="Arial" panose="020B0604020202020204" pitchFamily="34" charset="0"/>
-              <a:buChar char="•"/>
-              <a:defRPr sz="1800" kern="1200">
-                <a:solidFill>
-                  <a:schemeClr val="tx1"/>
-                </a:solidFill>
-                <a:latin typeface="+mn-lt"/>
-                <a:ea typeface="+mn-ea"/>
-                <a:cs typeface="+mn-cs"/>
-              </a:defRPr>
-            </a:lvl4pPr>
-            <a:lvl5pPr marL="2057400" indent="-228600" algn="l" defTabSz="914400" rtl="0" eaLnBrk="1" latinLnBrk="0" hangingPunct="1">
-              <a:lnSpc>
-                <a:spcPct val="90000"/>
-              </a:lnSpc>
-              <a:spcBef>
-                <a:spcPts val="500"/>
-              </a:spcBef>
-              <a:buFont typeface="Arial" panose="020B0604020202020204" pitchFamily="34" charset="0"/>
-              <a:buChar char="•"/>
-              <a:defRPr sz="1800" kern="1200">
-                <a:solidFill>
-                  <a:schemeClr val="tx1"/>
-                </a:solidFill>
-                <a:latin typeface="+mn-lt"/>
-                <a:ea typeface="+mn-ea"/>
-                <a:cs typeface="+mn-cs"/>
-              </a:defRPr>
-            </a:lvl5pPr>
-            <a:lvl6pPr marL="2514600" indent="-228600" algn="l" defTabSz="914400" rtl="0" eaLnBrk="1" latinLnBrk="0" hangingPunct="1">
-              <a:lnSpc>
-                <a:spcPct val="90000"/>
-              </a:lnSpc>
-              <a:spcBef>
-                <a:spcPts val="500"/>
-              </a:spcBef>
-              <a:buFont typeface="Arial" panose="020B0604020202020204" pitchFamily="34" charset="0"/>
-              <a:buChar char="•"/>
-              <a:defRPr sz="1800" kern="1200">
-                <a:solidFill>
-                  <a:schemeClr val="tx1"/>
-                </a:solidFill>
-                <a:latin typeface="+mn-lt"/>
-                <a:ea typeface="+mn-ea"/>
-                <a:cs typeface="+mn-cs"/>
-              </a:defRPr>
-            </a:lvl6pPr>
-            <a:lvl7pPr marL="2971800" indent="-228600" algn="l" defTabSz="914400" rtl="0" eaLnBrk="1" latinLnBrk="0" hangingPunct="1">
-              <a:lnSpc>
-                <a:spcPct val="90000"/>
-              </a:lnSpc>
-              <a:spcBef>
-                <a:spcPts val="500"/>
-              </a:spcBef>
-              <a:buFont typeface="Arial" panose="020B0604020202020204" pitchFamily="34" charset="0"/>
-              <a:buChar char="•"/>
-              <a:defRPr sz="1800" kern="1200">
-                <a:solidFill>
-                  <a:schemeClr val="tx1"/>
-                </a:solidFill>
-                <a:latin typeface="+mn-lt"/>
-                <a:ea typeface="+mn-ea"/>
-                <a:cs typeface="+mn-cs"/>
-              </a:defRPr>
-            </a:lvl7pPr>
-            <a:lvl8pPr marL="3429000" indent="-228600" algn="l" defTabSz="914400" rtl="0" eaLnBrk="1" latinLnBrk="0" hangingPunct="1">
-              <a:lnSpc>
-                <a:spcPct val="90000"/>
-              </a:lnSpc>
-              <a:spcBef>
-                <a:spcPts val="500"/>
-              </a:spcBef>
-              <a:buFont typeface="Arial" panose="020B0604020202020204" pitchFamily="34" charset="0"/>
-              <a:buChar char="•"/>
-              <a:defRPr sz="1800" kern="1200">
-                <a:solidFill>
-                  <a:schemeClr val="tx1"/>
-                </a:solidFill>
-                <a:latin typeface="+mn-lt"/>
-                <a:ea typeface="+mn-ea"/>
-                <a:cs typeface="+mn-cs"/>
-              </a:defRPr>
-            </a:lvl8pPr>
-            <a:lvl9pPr marL="3886200" indent="-228600" algn="l" defTabSz="914400" rtl="0" eaLnBrk="1" latinLnBrk="0" hangingPunct="1">
-              <a:lnSpc>
-                <a:spcPct val="90000"/>
-              </a:lnSpc>
-              <a:spcBef>
-                <a:spcPts val="500"/>
-              </a:spcBef>
-              <a:buFont typeface="Arial" panose="020B0604020202020204" pitchFamily="34" charset="0"/>
-              <a:buChar char="•"/>
-              <a:defRPr sz="1800" kern="1200">
-                <a:solidFill>
-                  <a:schemeClr val="tx1"/>
-                </a:solidFill>
-                <a:latin typeface="+mn-lt"/>
-                <a:ea typeface="+mn-ea"/>
-                <a:cs typeface="+mn-cs"/>
-              </a:defRPr>
-            </a:lvl9pPr>
-          </a:lstStyle>
-          <a:p>
-            <a:pPr marL="457200" indent="-342900">
-              <a:spcBef>
-                <a:spcPts val="0"/>
-              </a:spcBef>
-              <a:buClr>
-                <a:srgbClr val="000000"/>
-              </a:buClr>
-              <a:buSzPts val="1800"/>
-              <a:buFont typeface="Arial" panose="020B0604020202020204" pitchFamily="34" charset="0"/>
-              <a:buChar char="●"/>
-            </a:pPr>
           </a:p>
         </p:txBody>
       </p:sp>
@@ -6944,29 +6715,6 @@
       </p:sp>
       <p:sp>
         <p:nvSpPr>
-          <p:cNvPr id="3" name="Content Placeholder 2">
-            <a:extLst>
-              <a:ext uri="{FF2B5EF4-FFF2-40B4-BE49-F238E27FC236}">
-                <a16:creationId xmlns:a16="http://schemas.microsoft.com/office/drawing/2014/main" id="{72F3CEA0-56CF-74FC-F219-A18A507E305D}"/>
-              </a:ext>
-            </a:extLst>
-          </p:cNvPr>
-          <p:cNvSpPr>
-            <a:spLocks noGrp="1"/>
-          </p:cNvSpPr>
-          <p:nvPr>
-            <p:ph idx="1"/>
-          </p:nvPr>
-        </p:nvSpPr>
-        <p:spPr/>
-        <p:txBody>
-          <a:bodyPr/>
-          <a:lstStyle/>
-          <a:p/>
-        </p:txBody>
-      </p:sp>
-      <p:sp>
-        <p:nvSpPr>
           <p:cNvPr id="5" name="Slide Number Placeholder 4">
             <a:extLst>
               <a:ext uri="{FF2B5EF4-FFF2-40B4-BE49-F238E27FC236}">
@@ -7908,29 +7656,6 @@
       </p:sp>
       <p:sp>
         <p:nvSpPr>
-          <p:cNvPr id="3" name="Content Placeholder 2">
-            <a:extLst>
-              <a:ext uri="{FF2B5EF4-FFF2-40B4-BE49-F238E27FC236}">
-                <a16:creationId xmlns:a16="http://schemas.microsoft.com/office/drawing/2014/main" id="{7545E2EC-3FBE-4EC2-3D8D-1AE3C6B8A0F5}"/>
-              </a:ext>
-            </a:extLst>
-          </p:cNvPr>
-          <p:cNvSpPr>
-            <a:spLocks noGrp="1"/>
-          </p:cNvSpPr>
-          <p:nvPr>
-            <p:ph idx="1"/>
-          </p:nvPr>
-        </p:nvSpPr>
-        <p:spPr/>
-        <p:txBody>
-          <a:bodyPr/>
-          <a:lstStyle/>
-          <a:p/>
-        </p:txBody>
-      </p:sp>
-      <p:sp>
-        <p:nvSpPr>
           <p:cNvPr id="5" name="Slide Number Placeholder 4">
             <a:extLst>
               <a:ext uri="{FF2B5EF4-FFF2-40B4-BE49-F238E27FC236}">
@@ -8954,29 +8679,6 @@
       </p:sp>
       <p:sp>
         <p:nvSpPr>
-          <p:cNvPr id="3" name="Content Placeholder 2">
-            <a:extLst>
-              <a:ext uri="{FF2B5EF4-FFF2-40B4-BE49-F238E27FC236}">
-                <a16:creationId xmlns:a16="http://schemas.microsoft.com/office/drawing/2014/main" id="{7A63E88A-2B51-8093-B7EE-324E57BC865A}"/>
-              </a:ext>
-            </a:extLst>
-          </p:cNvPr>
-          <p:cNvSpPr>
-            <a:spLocks noGrp="1"/>
-          </p:cNvSpPr>
-          <p:nvPr>
-            <p:ph idx="1"/>
-          </p:nvPr>
-        </p:nvSpPr>
-        <p:spPr/>
-        <p:txBody>
-          <a:bodyPr/>
-          <a:lstStyle/>
-          <a:p/>
-        </p:txBody>
-      </p:sp>
-      <p:sp>
-        <p:nvSpPr>
           <p:cNvPr id="5" name="Slide Number Placeholder 4">
             <a:extLst>
               <a:ext uri="{FF2B5EF4-FFF2-40B4-BE49-F238E27FC236}">
@@ -9745,7 +9447,7 @@
           <a:lstStyle/>
           <a:p>
             <a:pPr>
-              <a:defRPr sz="1100">
+              <a:defRPr sz="1050">
                 <a:solidFill>
                   <a:srgbClr val="475569"/>
                 </a:solidFill>
@@ -10125,29 +9827,6 @@
       </p:sp>
       <p:sp>
         <p:nvSpPr>
-          <p:cNvPr id="3" name="Content Placeholder 2">
-            <a:extLst>
-              <a:ext uri="{FF2B5EF4-FFF2-40B4-BE49-F238E27FC236}">
-                <a16:creationId xmlns:a16="http://schemas.microsoft.com/office/drawing/2014/main" id="{064C7E31-37D1-BB5A-12F5-46F7C1BE0D6F}"/>
-              </a:ext>
-            </a:extLst>
-          </p:cNvPr>
-          <p:cNvSpPr>
-            <a:spLocks noGrp="1"/>
-          </p:cNvSpPr>
-          <p:nvPr>
-            <p:ph idx="1"/>
-          </p:nvPr>
-        </p:nvSpPr>
-        <p:spPr/>
-        <p:txBody>
-          <a:bodyPr/>
-          <a:lstStyle/>
-          <a:p/>
-        </p:txBody>
-      </p:sp>
-      <p:sp>
-        <p:nvSpPr>
           <p:cNvPr id="5" name="Slide Number Placeholder 4">
             <a:extLst>
               <a:ext uri="{FF2B5EF4-FFF2-40B4-BE49-F238E27FC236}">
@@ -11887,29 +11566,6 @@
       </p:sp>
       <p:sp>
         <p:nvSpPr>
-          <p:cNvPr id="3" name="Content Placeholder 2">
-            <a:extLst>
-              <a:ext uri="{FF2B5EF4-FFF2-40B4-BE49-F238E27FC236}">
-                <a16:creationId xmlns:a16="http://schemas.microsoft.com/office/drawing/2014/main" id="{B8080238-2735-5AE5-6AF7-DD1C6FCF59EA}"/>
-              </a:ext>
-            </a:extLst>
-          </p:cNvPr>
-          <p:cNvSpPr>
-            <a:spLocks noGrp="1"/>
-          </p:cNvSpPr>
-          <p:nvPr>
-            <p:ph idx="1"/>
-          </p:nvPr>
-        </p:nvSpPr>
-        <p:spPr/>
-        <p:txBody>
-          <a:bodyPr/>
-          <a:lstStyle/>
-          <a:p/>
-        </p:txBody>
-      </p:sp>
-      <p:sp>
-        <p:nvSpPr>
           <p:cNvPr id="5" name="Slide Number Placeholder 4">
             <a:extLst>
               <a:ext uri="{FF2B5EF4-FFF2-40B4-BE49-F238E27FC236}">
@@ -14272,29 +13928,6 @@
       </p:sp>
       <p:sp>
         <p:nvSpPr>
-          <p:cNvPr id="3" name="Content Placeholder 2">
-            <a:extLst>
-              <a:ext uri="{FF2B5EF4-FFF2-40B4-BE49-F238E27FC236}">
-                <a16:creationId xmlns:a16="http://schemas.microsoft.com/office/drawing/2014/main" id="{E4E9C6AD-4E12-E613-16D6-CE1D1A4612B1}"/>
-              </a:ext>
-            </a:extLst>
-          </p:cNvPr>
-          <p:cNvSpPr>
-            <a:spLocks noGrp="1"/>
-          </p:cNvSpPr>
-          <p:nvPr>
-            <p:ph idx="1"/>
-          </p:nvPr>
-        </p:nvSpPr>
-        <p:spPr/>
-        <p:txBody>
-          <a:bodyPr/>
-          <a:lstStyle/>
-          <a:p/>
-        </p:txBody>
-      </p:sp>
-      <p:sp>
-        <p:nvSpPr>
           <p:cNvPr id="5" name="Slide Number Placeholder 4">
             <a:extLst>
               <a:ext uri="{FF2B5EF4-FFF2-40B4-BE49-F238E27FC236}">
@@ -15493,29 +15126,6 @@
               <a:t>Conclusion</a:t>
             </a:r>
           </a:p>
-        </p:txBody>
-      </p:sp>
-      <p:sp>
-        <p:nvSpPr>
-          <p:cNvPr id="3" name="Content Placeholder 2">
-            <a:extLst>
-              <a:ext uri="{FF2B5EF4-FFF2-40B4-BE49-F238E27FC236}">
-                <a16:creationId xmlns:a16="http://schemas.microsoft.com/office/drawing/2014/main" id="{B3CC2BDB-F5D4-C088-74B2-AB49DBCE28B5}"/>
-              </a:ext>
-            </a:extLst>
-          </p:cNvPr>
-          <p:cNvSpPr>
-            <a:spLocks noGrp="1"/>
-          </p:cNvSpPr>
-          <p:nvPr>
-            <p:ph idx="1"/>
-          </p:nvPr>
-        </p:nvSpPr>
-        <p:spPr/>
-        <p:txBody>
-          <a:bodyPr/>
-          <a:lstStyle/>
-          <a:p/>
         </p:txBody>
       </p:sp>
       <p:sp>

</xml_diff>